<commit_message>
Fix the figure's title: three interventions attach, not four conditions
Only three of the four conditions attach anywhere. The fourth, original policy,
is the absence of all three -- so "where the four conditions attach" implies a
fourth attachment point that does not exist. Splitting the words fixes it:
four conditions, three interventions, with the subtitle naming the fourth
explicitly so it does not read as missing.

Applied to the title and speaker notes in the generator and to the note block
in the SVG.

Co-Authored-By: Claude Opus 5 <noreply@anthropic.com>
Claude-Session: https://claude.ai/code/session_011USoCwMtkSq1wKhwTPjNT9
</commit_message>
<xml_diff>
--- a/experiments/figures/hook_points.pptx
+++ b/experiments/figures/hook_points.pptx
@@ -502,7 +502,7 @@
           <a:p>
             <a:r>
               <a:rPr lang="en-US" dirty="0"/>
-              <a:t>Methods figure for the four-condition grid: original policy, fixed foveation (hook A), action repeat (hook B), fixed depth pruning (hook C). All shapes are native PowerPoint objects and can be edited directly.</a:t>
+              <a:t>Methods figure for the four-condition grid. Three of the four attach somewhere -- fixed foveation (hook A), action repeat (hook B), fixed depth pruning (hook C); the fourth, original policy, is the same loop with all three off. All shapes are native PowerPoint objects and can be edited directly.</a:t>
             </a:r>
             <a:endParaRPr lang="en-US" dirty="0"/>
           </a:p>
@@ -908,7 +908,7 @@
                 <a:ea typeface="Calibri" pitchFamily="34" charset="-122"/>
                 <a:cs typeface="Calibri" pitchFamily="34" charset="-120"/>
               </a:rPr>
-              <a:t>Where the four conditions attach</a:t>
+              <a:t>Where the three interventions attach</a:t>
             </a:r>
             <a:endParaRPr lang="en-US" sz="3200" dirty="0"/>
           </a:p>
@@ -947,7 +947,7 @@
                 <a:ea typeface="Calibri" pitchFamily="34" charset="-122"/>
                 <a:cs typeface="Calibri" pitchFamily="34" charset="-120"/>
               </a:rPr>
-              <a:t>Every hook attaches outside the frozen weights.  Original policy is this same loop with all three off.</a:t>
+              <a:t>Every hook attaches outside the frozen weights.  The fourth condition, Original policy, is this same loop with all three off.</a:t>
             </a:r>
             <a:endParaRPr lang="en-US" sz="1300" dirty="0"/>
           </a:p>

</xml_diff>